<commit_message>
Rapport et soutenance : extensions 2 et 4
</commit_message>
<xml_diff>
--- a/soutenance/soutenance_segmentation_bancaire.pptx
+++ b/soutenance/soutenance_segmentation_bancaire.pptx
@@ -2587,7 +2587,7 @@
           <a:lstStyle/>
           <a:p>
             <a:r>
-              <a:t>Les limites, à dire clairement. Les silhouettes sont autour de 0,2 : les segments se chevauchent. S1 et S2 se distinguent surtout par la période du contact, pas par ce que le client est. Le fichier n'a ni revenu ni solde. Et k = 4 est un choix métier. J'ai mesuré ce poids du contexte : sans les trois indicateurs économiques, seul l'historique de contact forme un groupe net, et la partition devient instable. Le graphique le montre : dans chaque groupe, la souscription est bien plus forte en période de taux bas ; à période égale, ce sont l'historique et le nombre d'appels qui discriminent, plus que la démographie. Deuxième extension : DBSCAN et l'Isolation Forest s'accordent sur un noyau de clients atypiques, surtout d'anciens souscripteurs, qui souscrivent à près de 50 %. Enfin, la règle d'affectation est déployée dans une petite application Streamlit.</a:t>
+              <a:t>Les limites, à dire clairement. Les silhouettes sont autour de 0,2 : les segments se chevauchent. S1 et S2 se distinguent surtout par la période du contact, pas par ce que le client est. Le fichier n'a ni revenu ni solde. Et k = 4 est un choix métier. J'ai mesuré ce poids du contexte : sans les trois indicateurs économiques, seul l'historique de contact forme un groupe net, et la partition devient instable. Le graphique le montre : dans chaque groupe, la souscription est bien plus forte en période de taux bas ; à période égale, ce sont l'historique et le nombre d'appels qui discriminent, plus que la démographie. Deuxième extension : DBSCAN et l'Isolation Forest s'accordent sur un noyau de clients atypiques, surtout d'anciens souscripteurs, qui souscrivent à près de 50 %. La sélection de variables le confirme : un wrapper bien construit montre que trois variables, l'Euribor, la confiance des ménages et l'historique, suffisent à reproduire la segmentation. J'ai aussi reproduit toute la démarche sur un second jeu, Online Retail, avec une segmentation RFM : un client sur six, les Champions, fait deux tiers du chiffre d'affaires, et cette fois c'est K-means qui est la méthode la plus stable. Enfin, la règle d'affectation est déployée dans une application Streamlit.</a:t>
             </a:r>
           </a:p>
         </p:txBody>
@@ -10913,11 +10913,11 @@
           <a:p>
             <a:pPr>
               <a:spcAft>
-                <a:spcPts val="1400"/>
+                <a:spcPts val="900"/>
               </a:spcAft>
             </a:pPr>
             <a:r>
-              <a:rPr sz="1000">
+              <a:rPr sz="850">
                 <a:solidFill>
                   <a:srgbClr val="059669"/>
                 </a:solidFill>
@@ -10926,23 +10926,23 @@
               <a:t>■  </a:t>
             </a:r>
             <a:r>
-              <a:rPr sz="1400">
+              <a:rPr sz="1250">
                 <a:solidFill>
                   <a:srgbClr val="0F172A"/>
                 </a:solidFill>
                 <a:latin typeface="Arial"/>
               </a:rPr>
-              <a:t>Sans le contexte, seul l'historique reste net (silhouette 0,12 ; stabilité 0,58)</a:t>
+              <a:t>Sans contexte : seul l'historique reste net (silhouette 0,12)</a:t>
             </a:r>
           </a:p>
           <a:p>
             <a:pPr>
               <a:spcAft>
-                <a:spcPts val="1400"/>
+                <a:spcPts val="900"/>
               </a:spcAft>
             </a:pPr>
             <a:r>
-              <a:rPr sz="1000">
+              <a:rPr sz="850">
                 <a:solidFill>
                   <a:srgbClr val="059669"/>
                 </a:solidFill>
@@ -10951,23 +10951,23 @@
               <a:t>■  </a:t>
             </a:r>
             <a:r>
-              <a:rPr sz="1400">
+              <a:rPr sz="1250">
                 <a:solidFill>
                   <a:srgbClr val="0F172A"/>
                 </a:solidFill>
                 <a:latin typeface="Arial"/>
               </a:rPr>
-              <a:t>Atypiques (DBSCAN + Isolation Forest) : anciens souscripteurs, ~50 % de souscription</a:t>
+              <a:t>Sélection de variables : 3 variables reproduisent la segmentation (ARI 0,97)</a:t>
             </a:r>
           </a:p>
           <a:p>
             <a:pPr>
               <a:spcAft>
-                <a:spcPts val="1400"/>
+                <a:spcPts val="900"/>
               </a:spcAft>
             </a:pPr>
             <a:r>
-              <a:rPr sz="1000">
+              <a:rPr sz="850">
                 <a:solidFill>
                   <a:srgbClr val="059669"/>
                 </a:solidFill>
@@ -10976,13 +10976,63 @@
               <a:t>■  </a:t>
             </a:r>
             <a:r>
-              <a:rPr sz="1400">
+              <a:rPr sz="1250">
                 <a:solidFill>
                   <a:srgbClr val="0F172A"/>
                 </a:solidFill>
                 <a:latin typeface="Arial"/>
               </a:rPr>
-              <a:t>Application Streamlit : affecte un ou plusieurs nouveaux clients à leur segment</a:t>
+              <a:t>Atypiques (DBSCAN + Isolation Forest) : ~50 % de souscription</a:t>
+            </a:r>
+          </a:p>
+          <a:p>
+            <a:pPr>
+              <a:spcAft>
+                <a:spcPts val="900"/>
+              </a:spcAft>
+            </a:pPr>
+            <a:r>
+              <a:rPr sz="850">
+                <a:solidFill>
+                  <a:srgbClr val="059669"/>
+                </a:solidFill>
+                <a:latin typeface="Arial"/>
+              </a:rPr>
+              <a:t>■  </a:t>
+            </a:r>
+            <a:r>
+              <a:rPr sz="1250">
+                <a:solidFill>
+                  <a:srgbClr val="0F172A"/>
+                </a:solidFill>
+                <a:latin typeface="Arial"/>
+              </a:rPr>
+              <a:t>Online Retail (RFM) : 16 % de Champions font 65 % du CA</a:t>
+            </a:r>
+          </a:p>
+          <a:p>
+            <a:pPr>
+              <a:spcAft>
+                <a:spcPts val="900"/>
+              </a:spcAft>
+            </a:pPr>
+            <a:r>
+              <a:rPr sz="850">
+                <a:solidFill>
+                  <a:srgbClr val="059669"/>
+                </a:solidFill>
+                <a:latin typeface="Arial"/>
+              </a:rPr>
+              <a:t>■  </a:t>
+            </a:r>
+            <a:r>
+              <a:rPr sz="1250">
+                <a:solidFill>
+                  <a:srgbClr val="0F172A"/>
+                </a:solidFill>
+                <a:latin typeface="Arial"/>
+              </a:rPr>
+              <a:t>Application Streamlit : affectation d'un client ou d'un fichier</a:t>
             </a:r>
           </a:p>
         </p:txBody>

</xml_diff>

<commit_message>
Soutenance : justification de l'implémentation personnelle de K-medoids (scikit-learn-extra incompatible avec NumPy 2 et Python 3.13)
</commit_message>
<xml_diff>
--- a/soutenance/soutenance_segmentation_bancaire.pptx
+++ b/soutenance/soutenance_segmentation_bancaire.pptx
@@ -2937,7 +2937,7 @@
           <a:lstStyle/>
           <a:p>
             <a:r>
-              <a:t>J'ai comparé neuf méthodes dans quatre familles. Chacune reçoit la représentation et la distance qui lui conviennent. Pour K-medoids, la bibliothèque scikit-learn-extra citée dans le sujet ne fonctionne plus avec NumPy 2 : le code l'utilise si elle est disponible, sinon il bascule sur ma propre implémentation du même algorithme. L'indice de Dunn est aussi codé à la main.</a:t>
+              <a:t>J'ai comparé neuf méthodes dans quatre familles. Chacune reçoit la représentation et la distance qui lui conviennent. Pour K-medoids, le sujet propose la bibliothèque scikit-learn-extra. Mais elle n'est plus mise à jour depuis 2023 : elle n'existe que pour NumPy 1 et pour Python 3.11 au plus, alors que mon environnement utilise Python 3.13 et NumPy 2. J'ai donc écrit K-medoids moi-même, avec le même algorithme : initialisation k-medoids++, puis on alterne l'affectation de chaque client au médoïde le plus proche et le remplacement de chaque médoïde par le client qui minimise la somme des distances de Gower dans son groupe. Si la bibliothèque est installée avec NumPy 1, le code l'utilise automatiquement. L'indice de Dunn est aussi codé à la main, comme le sujet le permet.</a:t>
             </a:r>
           </a:p>
         </p:txBody>
@@ -18648,7 +18648,7 @@
         <p:spPr>
           <a:xfrm>
             <a:off x="502920" y="5212080"/>
-            <a:ext cx="11186160" cy="502920"/>
+            <a:ext cx="11186160" cy="850000"/>
           </a:xfrm>
           <a:prstGeom prst="roundRect">
             <a:avLst>
@@ -18692,7 +18692,7 @@
         <p:spPr>
           <a:xfrm>
             <a:off x="777240" y="5212080"/>
-            <a:ext cx="10637520" cy="502920"/>
+            <a:ext cx="10637520" cy="850000"/>
           </a:xfrm>
           <a:prstGeom prst="rect">
             <a:avLst/>
@@ -18707,13 +18707,29 @@
           <a:p>
             <a:pPr algn="l"/>
             <a:r>
-              <a:rPr sz="1300" b="0">
+              <a:rPr sz="1300" b="1">
                 <a:solidFill>
                   <a:srgbClr val="0F172A"/>
                 </a:solidFill>
                 <a:latin typeface="Arial"/>
               </a:rPr>
-              <a:t>K-medoids et indice de Dunn : implémentations personnelles (scikit-learn-extra est incompatible avec NumPy 2).</a:t>
+              <a:t>K-medoids et indice de Dunn : implémentations personnelles.</a:t>
+            </a:r>
+          </a:p>
+          <a:p>
+            <a:pPr algn="l">
+              <a:spcBef>
+                <a:spcPts val="300"/>
+              </a:spcBef>
+            </a:pPr>
+            <a:r>
+              <a:rPr sz="1150" b="0">
+                <a:solidFill>
+                  <a:srgbClr val="475569"/>
+                </a:solidFill>
+                <a:latin typeface="Arial"/>
+              </a:rPr>
+              <a:t>scikit-learn-extra (cité dans le sujet) n'existe que pour NumPy 1 et Python ≤ 3.11, sans mise à jour depuis 2023 ; le projet tourne sous Python 3.13 et NumPy 2. Même algorithme : initialisation k-medoids++, affectation puis mise à jour des médoïdes.</a:t>
             </a:r>
           </a:p>
         </p:txBody>

</xml_diff>

<commit_message>
Lien du dépôt GitHub dans le rapport (page de titre, introduction) et sur la couverture de la soutenance
</commit_message>
<xml_diff>
--- a/soutenance/soutenance_segmentation_bancaire.pptx
+++ b/soutenance/soutenance_segmentation_bancaire.pptx
@@ -7364,6 +7364,77 @@
           </a:p>
         </p:txBody>
       </p:sp>
+      <p:sp>
+        <p:nvSpPr>
+          <p:cNvPr id="32" name="TextBox 32"/>
+          <p:cNvSpPr txBox="1"/>
+          <p:nvPr/>
+        </p:nvSpPr>
+        <p:spPr>
+          <a:xfrm>
+            <a:off x="685800" y="5897880"/>
+            <a:ext cx="8000000" cy="228600"/>
+          </a:xfrm>
+          <a:prstGeom prst="rect">
+            <a:avLst/>
+          </a:prstGeom>
+          <a:noFill/>
+        </p:spPr>
+        <p:txBody>
+          <a:bodyPr wrap="square" lIns="0" rIns="0" tIns="0" bIns="0" anchor="t">
+            <a:spAutoFit/>
+          </a:bodyPr>
+          <a:lstStyle/>
+          <a:p>
+            <a:pPr algn="l"/>
+            <a:r>
+              <a:rPr sz="1000" b="1">
+                <a:solidFill>
+                  <a:srgbClr val="94A3B8"/>
+                </a:solidFill>
+                <a:latin typeface="Arial"/>
+              </a:rPr>
+              <a:t>CODE SOURCE</a:t>
+            </a:r>
+          </a:p>
+        </p:txBody>
+      </p:sp>
+      <p:sp>
+        <p:nvSpPr>
+          <p:cNvPr id="33" name="TextBox 33"/>
+          <p:cNvSpPr txBox="1"/>
+          <p:nvPr/>
+        </p:nvSpPr>
+        <p:spPr>
+          <a:xfrm>
+            <a:off x="685800" y="6153912"/>
+            <a:ext cx="8000000" cy="457200"/>
+          </a:xfrm>
+          <a:prstGeom prst="rect">
+            <a:avLst/>
+          </a:prstGeom>
+          <a:noFill/>
+        </p:spPr>
+        <p:txBody>
+          <a:bodyPr wrap="square" lIns="0" rIns="0" tIns="0" bIns="0" anchor="t">
+            <a:spAutoFit/>
+          </a:bodyPr>
+          <a:lstStyle/>
+          <a:p>
+            <a:pPr algn="l"/>
+            <a:r>
+              <a:rPr sz="1300" b="1">
+                <a:solidFill>
+                  <a:srgbClr val="0F172A"/>
+                </a:solidFill>
+                <a:latin typeface="Arial"/>
+                <a:hlinkClick r:id="rId3"/>
+              </a:rPr>
+              <a:t>github.com/Nokho11/segmentation-bancaire</a:t>
+            </a:r>
+          </a:p>
+        </p:txBody>
+      </p:sp>
     </p:spTree>
   </p:cSld>
   <p:clrMapOvr>
@@ -11914,6 +11985,7 @@
                   <a:srgbClr val="0F172A"/>
                 </a:solidFill>
                 <a:latin typeface="Arial"/>
+                <a:hlinkClick r:id="rId3"/>
               </a:rPr>
               <a:t>github.com/Nokho11/segmentation-bancaire</a:t>
             </a:r>

</xml_diff>

<commit_message>
Correction : ARI bootstrap de K-means à k = 4 arrondi à 0,71 (et non 0,72)
</commit_message>
<xml_diff>
--- a/soutenance/soutenance_segmentation_bancaire.pptx
+++ b/soutenance/soutenance_segmentation_bancaire.pptx
@@ -3147,7 +3147,7 @@
           <a:lstStyle/>
           <a:p>
             <a:r>
-              <a:t>Sélection en quatre temps. Un filtre métier : 3 ou 4 groupes, chacun d'au moins 5 % des clients. Puis un classement sur les quatre indices internes seulement : y n'intervient pas dans le choix, sinon le raisonnement serait circulaire. Ward à 4 groupes est premier : meilleure silhouette, meilleur Davies-Bouldin, meilleur Dunn. Troisième étape, la stabilité : en bootstrap, Ward obtient 0,93 à k = 4 contre 0,72 pour K-means. Enfin, l'ARI calculé avec y sert seulement de contrôle : Ward a aussi le meilleur. Je retiens donc la CAH de Ward à quatre segments, en assumant le compromis : la structure la plus nette est à deux groupes. Ward ne passe pas à l'échelle de 41 000 clients : j'affecte chaque client au centre le plus proche, ce qui reproduit Ward à 98 %.</a:t>
+              <a:t>Sélection en quatre temps. Un filtre métier : 3 ou 4 groupes, chacun d'au moins 5 % des clients. Puis un classement sur les quatre indices internes seulement : y n'intervient pas dans le choix, sinon le raisonnement serait circulaire. Ward à 4 groupes est premier : meilleure silhouette, meilleur Davies-Bouldin, meilleur Dunn. Troisième étape, la stabilité : en bootstrap, Ward obtient 0,93 à k = 4 contre 0,71 pour K-means. Enfin, l'ARI calculé avec y sert seulement de contrôle : Ward a aussi le meilleur. Je retiens donc la CAH de Ward à quatre segments, en assumant le compromis : la structure la plus nette est à deux groupes. Ward ne passe pas à l'échelle de 41 000 clients : j'affecte chaque client au centre le plus proche, ce qui reproduit Ward à 98 %.</a:t>
             </a:r>
           </a:p>
         </p:txBody>
@@ -26105,7 +26105,7 @@
                 </a:solidFill>
                 <a:latin typeface="Arial"/>
               </a:rPr>
-              <a:t>ARI bootstrap (K-means : 0,72)</a:t>
+              <a:t>ARI bootstrap (K-means : 0,71)</a:t>
             </a:r>
           </a:p>
         </p:txBody>

</xml_diff>